<commit_message>
Use neutral sample references on the slide templates
The figure slides of the lab templates show Author+ 25 MNRAS, Author+ 24 Science, Author & Author 25 ApJL and Author+ 26a A&A in place of real papers, so the templates carry no names. A test requires every filled reference box on the sample slides to start with Author. The .pptx, the Keynote theme and both hashes are rebuilt from the new source.
</commit_message>
<xml_diff>
--- a/templates/Forming Worlds.pptx
+++ b/templates/Forming Worlds.pptx
@@ -3462,7 +3462,7 @@
           <a:lstStyle/>
           <a:p>
             <a:r>
-              <a:t>Nicholls+ 25 </a:t>
+              <a:t>Author+ 25 </a:t>
             </a:r>
             <a:r>
               <a:rPr i="1"/>
@@ -3584,7 +3584,7 @@
           <a:lstStyle/>
           <a:p>
             <a:r>
-              <a:t>Lichtenberg+ 25 </a:t>
+              <a:t>Author+ 24 </a:t>
             </a:r>
             <a:r>
               <a:rPr i="1"/>
@@ -3672,7 +3672,7 @@
           <a:lstStyle/>
           <a:p>
             <a:r>
-              <a:t>Teske+ 25 </a:t>
+              <a:t>Author &amp; Author 25 </a:t>
             </a:r>
             <a:r>
               <a:rPr i="1"/>
@@ -3697,11 +3697,11 @@
           <a:lstStyle/>
           <a:p>
             <a:r>
-              <a:t>Lichtenberg &amp; Miguel 25 </a:t>
+              <a:t>Author+ 26a </a:t>
             </a:r>
             <a:r>
               <a:rPr i="1"/>
-              <a:t>Treatise on Geochemistry</a:t>
+              <a:t>A&amp;A</a:t>
             </a:r>
           </a:p>
         </p:txBody>

</xml_diff>